<commit_message>
Adăugare documentație PDF și PPT + Readme.
</commit_message>
<xml_diff>
--- a/Documentations/The-Inventory-EN.pptx
+++ b/Documentations/The-Inventory-EN.pptx
@@ -5,7 +5,7 @@
     <p:sldMasterId id="2147483648" r:id="rId1"/>
   </p:sldMasterIdLst>
   <p:notesMasterIdLst>
-    <p:notesMasterId r:id="rId10"/>
+    <p:notesMasterId r:id="rId11"/>
   </p:notesMasterIdLst>
   <p:sldIdLst>
     <p:sldId id="256" r:id="rId2"/>
@@ -15,7 +15,8 @@
     <p:sldId id="259" r:id="rId6"/>
     <p:sldId id="260" r:id="rId7"/>
     <p:sldId id="264" r:id="rId8"/>
-    <p:sldId id="261" r:id="rId9"/>
+    <p:sldId id="266" r:id="rId9"/>
+    <p:sldId id="261" r:id="rId10"/>
   </p:sldIdLst>
   <p:sldSz cx="9144000" cy="5143500" type="screen16x9"/>
   <p:notesSz cx="5143500" cy="9144000"/>
@@ -813,7 +814,7 @@
           <a:p>
             <a:fld id="{F7021451-1387-4CA6-816F-3879F97B5CBC}" type="slidenum">
               <a:rPr lang="en-US"/>
-              <a:t>8</a:t>
+              <a:t>9</a:t>
             </a:fld>
             <a:endParaRPr lang="en-US"/>
           </a:p>
@@ -9458,6 +9459,184 @@
 
 <file path=ppt/slides/slide8.xml><?xml version="1.0" encoding="utf-8"?>
 <p:sld xmlns:a="http://schemas.openxmlformats.org/drawingml/2006/main" xmlns:r="http://schemas.openxmlformats.org/officeDocument/2006/relationships" xmlns:p="http://schemas.openxmlformats.org/presentationml/2006/main">
+  <p:cSld>
+    <p:bg>
+      <p:bgPr>
+        <a:solidFill>
+          <a:srgbClr val="080D1A"/>
+        </a:solidFill>
+        <a:effectLst/>
+      </p:bgPr>
+    </p:bg>
+    <p:spTree>
+      <p:nvGrpSpPr>
+        <p:cNvPr id="1" name=""/>
+        <p:cNvGrpSpPr/>
+        <p:nvPr/>
+      </p:nvGrpSpPr>
+      <p:grpSpPr>
+        <a:xfrm>
+          <a:off x="0" y="0"/>
+          <a:ext cx="0" cy="0"/>
+          <a:chOff x="0" y="0"/>
+          <a:chExt cx="0" cy="0"/>
+        </a:xfrm>
+      </p:grpSpPr>
+      <p:pic>
+        <p:nvPicPr>
+          <p:cNvPr id="4" name="Imagine 3">
+            <a:extLst>
+              <a:ext uri="{FF2B5EF4-FFF2-40B4-BE49-F238E27FC236}">
+                <a16:creationId xmlns:a16="http://schemas.microsoft.com/office/drawing/2014/main" id="{41002AD1-67C7-CFC0-4279-979F8572D976}"/>
+              </a:ext>
+            </a:extLst>
+          </p:cNvPr>
+          <p:cNvPicPr>
+            <a:picLocks noChangeAspect="1"/>
+          </p:cNvPicPr>
+          <p:nvPr/>
+        </p:nvPicPr>
+        <p:blipFill>
+          <a:blip r:embed="rId2"/>
+          <a:stretch>
+            <a:fillRect/>
+          </a:stretch>
+        </p:blipFill>
+        <p:spPr>
+          <a:xfrm>
+            <a:off x="2894569" y="106680"/>
+            <a:ext cx="3354861" cy="1096781"/>
+          </a:xfrm>
+          <a:prstGeom prst="rect">
+            <a:avLst/>
+          </a:prstGeom>
+        </p:spPr>
+      </p:pic>
+      <p:sp>
+        <p:nvSpPr>
+          <p:cNvPr id="7" name="Shape 16">
+            <a:extLst>
+              <a:ext uri="{FF2B5EF4-FFF2-40B4-BE49-F238E27FC236}">
+                <a16:creationId xmlns:a16="http://schemas.microsoft.com/office/drawing/2014/main" id="{EAD13ABF-C891-C86B-7074-0FA17B0C1B9C}"/>
+              </a:ext>
+            </a:extLst>
+          </p:cNvPr>
+          <p:cNvSpPr/>
+          <p:nvPr/>
+        </p:nvSpPr>
+        <p:spPr>
+          <a:xfrm>
+            <a:off x="347471" y="1414248"/>
+            <a:ext cx="8449056" cy="384048"/>
+          </a:xfrm>
+          <a:prstGeom prst="rect">
+            <a:avLst/>
+          </a:prstGeom>
+          <a:solidFill>
+            <a:srgbClr val="0E1628"/>
+          </a:solidFill>
+          <a:ln w="38100">
+            <a:solidFill>
+              <a:srgbClr val="38BDF8"/>
+            </a:solidFill>
+            <a:prstDash val="solid"/>
+          </a:ln>
+        </p:spPr>
+      </p:sp>
+      <p:sp>
+        <p:nvSpPr>
+          <p:cNvPr id="9" name="CasetăText 8">
+            <a:extLst>
+              <a:ext uri="{FF2B5EF4-FFF2-40B4-BE49-F238E27FC236}">
+                <a16:creationId xmlns:a16="http://schemas.microsoft.com/office/drawing/2014/main" id="{3A7FA51B-09B4-967F-C1AC-878A9D6A71B7}"/>
+              </a:ext>
+            </a:extLst>
+          </p:cNvPr>
+          <p:cNvSpPr txBox="1"/>
+          <p:nvPr/>
+        </p:nvSpPr>
+        <p:spPr>
+          <a:xfrm>
+            <a:off x="2285998" y="1430988"/>
+            <a:ext cx="4572000" cy="369332"/>
+          </a:xfrm>
+          <a:prstGeom prst="rect">
+            <a:avLst/>
+          </a:prstGeom>
+          <a:noFill/>
+        </p:spPr>
+        <p:txBody>
+          <a:bodyPr wrap="square">
+            <a:spAutoFit/>
+          </a:bodyPr>
+          <a:lstStyle/>
+          <a:p>
+            <a:pPr algn="ctr"/>
+            <a:r>
+              <a:rPr lang="en-US" b="1" dirty="0">
+                <a:solidFill>
+                  <a:srgbClr val="8B96A8"/>
+                </a:solidFill>
+                <a:latin typeface="Calibri" pitchFamily="34" charset="0"/>
+                <a:ea typeface="Calibri" pitchFamily="34" charset="-122"/>
+                <a:cs typeface="Calibri" pitchFamily="34" charset="-120"/>
+                <a:hlinkClick r:id="rId3"/>
+              </a:rPr>
+              <a:t>https://fermo.top/The-inventory/</a:t>
+            </a:r>
+            <a:endParaRPr lang="en-US" sz="1800" b="1" dirty="0"/>
+          </a:p>
+        </p:txBody>
+      </p:sp>
+      <p:pic>
+        <p:nvPicPr>
+          <p:cNvPr id="19" name="Grafic 18">
+            <a:extLst>
+              <a:ext uri="{FF2B5EF4-FFF2-40B4-BE49-F238E27FC236}">
+                <a16:creationId xmlns:a16="http://schemas.microsoft.com/office/drawing/2014/main" id="{C82636AF-A776-4B45-A003-AD4C32B35C95}"/>
+              </a:ext>
+            </a:extLst>
+          </p:cNvPr>
+          <p:cNvPicPr>
+            <a:picLocks noChangeAspect="1"/>
+          </p:cNvPicPr>
+          <p:nvPr/>
+        </p:nvPicPr>
+        <p:blipFill>
+          <a:blip r:embed="rId4"/>
+          <a:srcRect/>
+          <a:stretch/>
+        </p:blipFill>
+        <p:spPr>
+          <a:xfrm>
+            <a:off x="3272332" y="2124535"/>
+            <a:ext cx="2599334" cy="2610652"/>
+          </a:xfrm>
+          <a:prstGeom prst="rect">
+            <a:avLst/>
+          </a:prstGeom>
+          <a:ln w="38100">
+            <a:solidFill>
+              <a:srgbClr val="38BDF8"/>
+            </a:solidFill>
+          </a:ln>
+        </p:spPr>
+      </p:pic>
+    </p:spTree>
+    <p:extLst>
+      <p:ext uri="{BB962C8B-B14F-4D97-AF65-F5344CB8AC3E}">
+        <p14:creationId xmlns:p14="http://schemas.microsoft.com/office/powerpoint/2010/main" val="1292600944"/>
+      </p:ext>
+    </p:extLst>
+  </p:cSld>
+  <p:clrMapOvr>
+    <a:masterClrMapping/>
+  </p:clrMapOvr>
+</p:sld>
+</file>
+
+<file path=ppt/slides/slide9.xml><?xml version="1.0" encoding="utf-8"?>
+<p:sld xmlns:a="http://schemas.openxmlformats.org/drawingml/2006/main" xmlns:r="http://schemas.openxmlformats.org/officeDocument/2006/relationships" xmlns:p="http://schemas.openxmlformats.org/presentationml/2006/main">
   <p:cSld name="Slide 6">
     <p:bg>
       <p:bgPr>
@@ -10525,31 +10704,6 @@
       </p:sp>
       <p:sp>
         <p:nvSpPr>
-          <p:cNvPr id="24" name="Shape 16"/>
-          <p:cNvSpPr/>
-          <p:nvPr/>
-        </p:nvSpPr>
-        <p:spPr>
-          <a:xfrm>
-            <a:off x="347472" y="4553712"/>
-            <a:ext cx="8449056" cy="384048"/>
-          </a:xfrm>
-          <a:prstGeom prst="rect">
-            <a:avLst/>
-          </a:prstGeom>
-          <a:solidFill>
-            <a:srgbClr val="0E1628"/>
-          </a:solidFill>
-          <a:ln w="12700">
-            <a:solidFill>
-              <a:srgbClr val="1C2A40"/>
-            </a:solidFill>
-            <a:prstDash val="solid"/>
-          </a:ln>
-        </p:spPr>
-      </p:sp>
-      <p:sp>
-        <p:nvSpPr>
           <p:cNvPr id="25" name="Text 17"/>
           <p:cNvSpPr/>
           <p:nvPr/>
@@ -10572,29 +10726,6 @@
             <a:pPr marL="0" indent="0" algn="ctr">
               <a:buNone/>
             </a:pPr>
-            <a:r>
-              <a:rPr lang="en-US" sz="1000" b="1" dirty="0">
-                <a:solidFill>
-                  <a:srgbClr val="8B96A8"/>
-                </a:solidFill>
-                <a:latin typeface="Calibri" pitchFamily="34" charset="0"/>
-                <a:ea typeface="Calibri" pitchFamily="34" charset="-122"/>
-                <a:cs typeface="Calibri" pitchFamily="34" charset="-120"/>
-                <a:hlinkClick r:id="rId8"/>
-              </a:rPr>
-              <a:t>fermo.top/The-inventory/  </a:t>
-            </a:r>
-            <a:r>
-              <a:rPr lang="en-US" sz="1000" b="1" dirty="0">
-                <a:solidFill>
-                  <a:srgbClr val="8B96A8"/>
-                </a:solidFill>
-                <a:latin typeface="Calibri" pitchFamily="34" charset="0"/>
-                <a:ea typeface="Calibri" pitchFamily="34" charset="-122"/>
-                <a:cs typeface="Calibri" pitchFamily="34" charset="-120"/>
-              </a:rPr>
-              <a:t>  ·  THE INVENTORY v1.0  ·  Strugariu Filip-Daniel  ·  © 2026</a:t>
-            </a:r>
             <a:endParaRPr lang="en-US" sz="1000" b="1" dirty="0"/>
           </a:p>
         </p:txBody>
@@ -10657,7 +10788,7 @@
           <p:nvPr/>
         </p:nvPicPr>
         <p:blipFill>
-          <a:blip r:embed="rId9"/>
+          <a:blip r:embed="rId8"/>
           <a:stretch>
             <a:fillRect/>
           </a:stretch>
@@ -10672,6 +10803,93 @@
           </a:prstGeom>
         </p:spPr>
       </p:pic>
+      <p:sp>
+        <p:nvSpPr>
+          <p:cNvPr id="29" name="Shape 16">
+            <a:extLst>
+              <a:ext uri="{FF2B5EF4-FFF2-40B4-BE49-F238E27FC236}">
+                <a16:creationId xmlns:a16="http://schemas.microsoft.com/office/drawing/2014/main" id="{48C4793F-E6AA-F4E8-02C1-136B68793BE3}"/>
+              </a:ext>
+            </a:extLst>
+          </p:cNvPr>
+          <p:cNvSpPr/>
+          <p:nvPr/>
+        </p:nvSpPr>
+        <p:spPr>
+          <a:xfrm>
+            <a:off x="375844" y="4494276"/>
+            <a:ext cx="8449056" cy="384048"/>
+          </a:xfrm>
+          <a:prstGeom prst="rect">
+            <a:avLst/>
+          </a:prstGeom>
+          <a:solidFill>
+            <a:srgbClr val="0E1628"/>
+          </a:solidFill>
+          <a:ln w="12700">
+            <a:solidFill>
+              <a:srgbClr val="1C2A40"/>
+            </a:solidFill>
+            <a:prstDash val="solid"/>
+          </a:ln>
+        </p:spPr>
+      </p:sp>
+      <p:sp>
+        <p:nvSpPr>
+          <p:cNvPr id="30" name="Text 17">
+            <a:extLst>
+              <a:ext uri="{FF2B5EF4-FFF2-40B4-BE49-F238E27FC236}">
+                <a16:creationId xmlns:a16="http://schemas.microsoft.com/office/drawing/2014/main" id="{0D760EAB-3D5A-80F4-FE1C-CA4AAE620F85}"/>
+              </a:ext>
+            </a:extLst>
+          </p:cNvPr>
+          <p:cNvSpPr/>
+          <p:nvPr/>
+        </p:nvSpPr>
+        <p:spPr>
+          <a:xfrm>
+            <a:off x="375844" y="4494276"/>
+            <a:ext cx="8449056" cy="384048"/>
+          </a:xfrm>
+          <a:prstGeom prst="rect">
+            <a:avLst/>
+          </a:prstGeom>
+          <a:noFill/>
+          <a:ln/>
+        </p:spPr>
+        <p:txBody>
+          <a:bodyPr wrap="square" rtlCol="0" anchor="ctr"/>
+          <a:lstStyle/>
+          <a:p>
+            <a:pPr marL="0" indent="0" algn="ctr">
+              <a:buNone/>
+            </a:pPr>
+            <a:r>
+              <a:rPr lang="en-US" sz="1000" b="1" dirty="0">
+                <a:solidFill>
+                  <a:srgbClr val="8B96A8"/>
+                </a:solidFill>
+                <a:latin typeface="Calibri" pitchFamily="34" charset="0"/>
+                <a:ea typeface="Calibri" pitchFamily="34" charset="-122"/>
+                <a:cs typeface="Calibri" pitchFamily="34" charset="-120"/>
+              </a:rPr>
+              <a:t>Thanks for your attention </a:t>
+            </a:r>
+            <a:r>
+              <a:rPr lang="ro-RO" sz="1000" b="1" dirty="0">
+                <a:solidFill>
+                  <a:srgbClr val="8B96A8"/>
+                </a:solidFill>
+                <a:latin typeface="Calibri" pitchFamily="34" charset="0"/>
+                <a:ea typeface="Calibri" pitchFamily="34" charset="-122"/>
+                <a:cs typeface="Calibri" pitchFamily="34" charset="-120"/>
+              </a:rPr>
+              <a:t>!</a:t>
+            </a:r>
+            <a:endParaRPr lang="en-US" sz="1000" b="1" dirty="0"/>
+          </a:p>
+        </p:txBody>
+      </p:sp>
     </p:spTree>
   </p:cSld>
   <p:clrMapOvr>

</xml_diff>

<commit_message>
Am adaugat un qr code independent(generat de mine) , aceasta este varianta dinaintea ultimului demo.
</commit_message>
<xml_diff>
--- a/Documentations/The-Inventory-EN.pptx
+++ b/Documentations/The-Inventory-EN.pptx
@@ -9590,7 +9590,7 @@
       </p:sp>
       <p:pic>
         <p:nvPicPr>
-          <p:cNvPr id="19" name="Grafic 18">
+          <p:cNvPr id="2" name="Grafic 18">
             <a:extLst>
               <a:ext uri="{FF2B5EF4-FFF2-40B4-BE49-F238E27FC236}">
                 <a16:creationId xmlns:a16="http://schemas.microsoft.com/office/drawing/2014/main" id="{C82636AF-A776-4B45-A003-AD4C32B35C95}"/>
@@ -9604,13 +9604,15 @@
         </p:nvPicPr>
         <p:blipFill>
           <a:blip r:embed="rId4"/>
-          <a:srcRect/>
-          <a:stretch/>
+          <a:srcRect l="5148" t="5116" r="6613" b="6060"/>
+          <a:stretch>
+            <a:fillRect/>
+          </a:stretch>
         </p:blipFill>
         <p:spPr>
           <a:xfrm>
-            <a:off x="3272332" y="2124535"/>
-            <a:ext cx="2599334" cy="2610652"/>
+            <a:off x="3272331" y="2124535"/>
+            <a:ext cx="2599334" cy="2616605"/>
           </a:xfrm>
           <a:prstGeom prst="rect">
             <a:avLst/>

</xml_diff>